<commit_message>
docs: record current Linux and Docker rerun
</commit_message>
<xml_diff>
--- a/submission/CjRepoMesh-technical-defense-2026-09-23.pptx
+++ b/submission/CjRepoMesh-technical-defense-2026-09-23.pptx
@@ -2,20 +2,20 @@
 <file path=ppt/presentation.xml><?xml version="1.0" encoding="utf-8"?>
 <p:presentation xmlns:p="http://schemas.openxmlformats.org/presentationml/2006/main">
   <p:sldMasterIdLst>
-    <p:sldMasterId xmlns:r="http://schemas.openxmlformats.org/officeDocument/2006/relationships" id="2147483648" r:id="Rf5fbc4eb3b9a4dff"/>
+    <p:sldMasterId xmlns:r="http://schemas.openxmlformats.org/officeDocument/2006/relationships" id="2147483648" r:id="R153d9861cb5d438c"/>
   </p:sldMasterIdLst>
   <p:notesMasterIdLst>
-    <p:notesMasterId xmlns:r="http://schemas.openxmlformats.org/officeDocument/2006/relationships" r:id="R59b93f9e63b04070"/>
+    <p:notesMasterId xmlns:r="http://schemas.openxmlformats.org/officeDocument/2006/relationships" r:id="R273255f8a67e42cb"/>
   </p:notesMasterIdLst>
   <p:sldIdLst>
-    <p:sldId xmlns:r="http://schemas.openxmlformats.org/officeDocument/2006/relationships" id="256" r:id="R55717e6643424daf"/>
-    <p:sldId xmlns:r="http://schemas.openxmlformats.org/officeDocument/2006/relationships" id="257" r:id="Raa395b4bac9b4726"/>
-    <p:sldId xmlns:r="http://schemas.openxmlformats.org/officeDocument/2006/relationships" id="258" r:id="R5704c5f84f564a71"/>
-    <p:sldId xmlns:r="http://schemas.openxmlformats.org/officeDocument/2006/relationships" id="259" r:id="R7006f9666a994f1b"/>
-    <p:sldId xmlns:r="http://schemas.openxmlformats.org/officeDocument/2006/relationships" id="260" r:id="Ra7cb43b13cd94c05"/>
-    <p:sldId xmlns:r="http://schemas.openxmlformats.org/officeDocument/2006/relationships" id="261" r:id="R5b594c419e3347eb"/>
-    <p:sldId xmlns:r="http://schemas.openxmlformats.org/officeDocument/2006/relationships" id="262" r:id="Rba1d55395be5410e"/>
-    <p:sldId xmlns:r="http://schemas.openxmlformats.org/officeDocument/2006/relationships" id="263" r:id="R4db0fa64e21e47a4"/>
+    <p:sldId xmlns:r="http://schemas.openxmlformats.org/officeDocument/2006/relationships" id="256" r:id="R393e36544806467c"/>
+    <p:sldId xmlns:r="http://schemas.openxmlformats.org/officeDocument/2006/relationships" id="257" r:id="Rf6c9f98b89ae4b28"/>
+    <p:sldId xmlns:r="http://schemas.openxmlformats.org/officeDocument/2006/relationships" id="258" r:id="R1ec8acb8abb94246"/>
+    <p:sldId xmlns:r="http://schemas.openxmlformats.org/officeDocument/2006/relationships" id="259" r:id="R58af050c331d474f"/>
+    <p:sldId xmlns:r="http://schemas.openxmlformats.org/officeDocument/2006/relationships" id="260" r:id="Rf73732c37ba34ed4"/>
+    <p:sldId xmlns:r="http://schemas.openxmlformats.org/officeDocument/2006/relationships" id="261" r:id="Rad41356e31fc4edf"/>
+    <p:sldId xmlns:r="http://schemas.openxmlformats.org/officeDocument/2006/relationships" id="262" r:id="Ra2b7bccef0de44d2"/>
+    <p:sldId xmlns:r="http://schemas.openxmlformats.org/officeDocument/2006/relationships" id="263" r:id="Ra30167e1887f45c0"/>
   </p:sldIdLst>
   <p:sldSz cx="12192000" cy="6858000"/>
   <p:notesSz cx="6858000" cy="9144000"/>
@@ -829,7 +829,7 @@
           </a:p>
           <a:p xmlns:a="http://schemas.openxmlformats.org/drawingml/2006/main">
             <a:r>
-              <a:t>讲述建议：65 秒。Linux 4/4 为测试提交 2bb1884 上完整四组回归，103.30 秒；后续 662935d 为多仓专项单组通过，非全量。Docker 9/9 为 c602c12 修复后两轮。官方差分 7/7；官方 HTTP LLT 夹具在原版与增强版各 16/16。不要说完整 Maple HLT/LLT 已通过。</a:t>
+              <a:t>讲述建议：65 秒。Linux 4/4 为提交 0f0e076 上完整四组回归，710.19 秒；该轮覆盖 662935d 后新增的篡改制品场景。Docker 9/9 在同一提交再次通过；c602c12 修复后此前还有两轮 9/9。官方差分 7/7；官方 HTTP LLT 夹具在原版与增强版各 16/16。不要说完整 Maple HLT/LLT 已通过。</a:t>
             </a:r>
           </a:p>
         </p:txBody>
@@ -1047,7 +1047,7 @@
   </p:cSld>
   <p:clrMap bg1="lt1" tx1="dk1" bg2="lt2" tx2="dk2" accent1="accent1" accent2="accent2" accent3="accent3" accent4="accent4" accent5="accent5" accent6="accent6" hlink="hlink" folHlink="folHlink"/>
   <p:sldLayoutIdLst>
-    <p:sldLayoutId xmlns:r="http://schemas.openxmlformats.org/officeDocument/2006/relationships" id="2147483649" r:id="R96d148b5fed14605"/>
+    <p:sldLayoutId xmlns:r="http://schemas.openxmlformats.org/officeDocument/2006/relationships" id="2147483649" r:id="R6c012ab0be204ef2"/>
   </p:sldLayoutIdLst>
   <p:txStyles>
     <p:titleStyle>
@@ -1598,7 +1598,7 @@
           <p:cNvPr id="6" name="">
             <a:extLst xmlns:a="http://schemas.openxmlformats.org/drawingml/2006/main">
               <a:ext uri="{FF2B5EF4-FFF2-40B4-BE49-F238E27FC236}">
-                <a16:creationId xmlns:a16="http://schemas.microsoft.com/office/drawing/2014/main" id="{470D2C5B-DA4D-4C92-AF37-95A53AA42F28}"/>
+                <a16:creationId xmlns:a16="http://schemas.microsoft.com/office/drawing/2014/main" id="{76BBF033-916F-4D0C-84ED-F34E6F9C052A}"/>
               </a:ext>
             </a:extLst>
           </p:cNvPr>
@@ -1655,7 +1655,7 @@
           <p:cNvPr id="2" name="">
             <a:extLst xmlns:a="http://schemas.openxmlformats.org/drawingml/2006/main">
               <a:ext uri="{FF2B5EF4-FFF2-40B4-BE49-F238E27FC236}">
-                <a16:creationId xmlns:a16="http://schemas.microsoft.com/office/drawing/2014/main" id="{D87A8816-CA58-46A9-81F5-C2DB3BCB556B}"/>
+                <a16:creationId xmlns:a16="http://schemas.microsoft.com/office/drawing/2014/main" id="{DE478696-7509-4A38-97C9-E7BADBDC3A5C}"/>
               </a:ext>
             </a:extLst>
           </p:cNvPr>
@@ -1712,7 +1712,7 @@
           <p:cNvPr id="3" name="">
             <a:extLst xmlns:a="http://schemas.openxmlformats.org/drawingml/2006/main">
               <a:ext uri="{FF2B5EF4-FFF2-40B4-BE49-F238E27FC236}">
-                <a16:creationId xmlns:a16="http://schemas.microsoft.com/office/drawing/2014/main" id="{EBDB36EF-3A7C-404B-AE5E-9468A30E3669}"/>
+                <a16:creationId xmlns:a16="http://schemas.microsoft.com/office/drawing/2014/main" id="{A2542FCF-07CD-4AFC-BE3D-3694AD0A8BE1}"/>
               </a:ext>
             </a:extLst>
           </p:cNvPr>
@@ -1742,7 +1742,7 @@
           <p:cNvPr id="4" name="">
             <a:extLst xmlns:a="http://schemas.openxmlformats.org/drawingml/2006/main">
               <a:ext uri="{FF2B5EF4-FFF2-40B4-BE49-F238E27FC236}">
-                <a16:creationId xmlns:a16="http://schemas.microsoft.com/office/drawing/2014/main" id="{EB60015D-1703-45C5-AFC5-3F01F7C48483}"/>
+                <a16:creationId xmlns:a16="http://schemas.microsoft.com/office/drawing/2014/main" id="{3ECB86C3-6DB2-4B24-999D-279864981A9A}"/>
               </a:ext>
             </a:extLst>
           </p:cNvPr>
@@ -1799,7 +1799,7 @@
           <p:cNvPr id="5" name="">
             <a:extLst xmlns:a="http://schemas.openxmlformats.org/drawingml/2006/main">
               <a:ext uri="{FF2B5EF4-FFF2-40B4-BE49-F238E27FC236}">
-                <a16:creationId xmlns:a16="http://schemas.microsoft.com/office/drawing/2014/main" id="{C6181E0B-2B14-41D6-B308-385C614FEFB6}"/>
+                <a16:creationId xmlns:a16="http://schemas.microsoft.com/office/drawing/2014/main" id="{0F74D0D4-126D-48AE-B66C-9DFF1BBAC2FE}"/>
               </a:ext>
             </a:extLst>
           </p:cNvPr>
@@ -1854,7 +1854,7 @@
     </p:spTree>
     <p:extLst>
       <p:ext uri="{BB962C8B-B14F-4D97-AF65-F5344CB8AC3E}">
-        <p14:creationId xmlns:p14="http://schemas.microsoft.com/office/powerpoint/2010/main" val="1738765294"/>
+        <p14:creationId xmlns:p14="http://schemas.microsoft.com/office/powerpoint/2010/main" val="1520567321"/>
       </p:ext>
     </p:extLst>
   </p:cSld>
@@ -1885,7 +1885,7 @@
           <p:cNvPr id="13" name="">
             <a:extLst xmlns:a="http://schemas.openxmlformats.org/drawingml/2006/main">
               <a:ext uri="{FF2B5EF4-FFF2-40B4-BE49-F238E27FC236}">
-                <a16:creationId xmlns:a16="http://schemas.microsoft.com/office/drawing/2014/main" id="{C3C6A7DF-73E0-44A5-9C1A-3309464125FC}"/>
+                <a16:creationId xmlns:a16="http://schemas.microsoft.com/office/drawing/2014/main" id="{425415E5-1F2F-4F0B-8544-61B3FC39FB81}"/>
               </a:ext>
             </a:extLst>
           </p:cNvPr>
@@ -1942,7 +1942,7 @@
           <p:cNvPr id="2" name="">
             <a:extLst xmlns:a="http://schemas.openxmlformats.org/drawingml/2006/main">
               <a:ext uri="{FF2B5EF4-FFF2-40B4-BE49-F238E27FC236}">
-                <a16:creationId xmlns:a16="http://schemas.microsoft.com/office/drawing/2014/main" id="{9A5AD096-34A5-4494-9EBC-A14306042480}"/>
+                <a16:creationId xmlns:a16="http://schemas.microsoft.com/office/drawing/2014/main" id="{6EB7142C-B465-4B02-8786-EA4B988FB47A}"/>
               </a:ext>
             </a:extLst>
           </p:cNvPr>
@@ -1972,7 +1972,7 @@
           <p:cNvPr id="3" name="">
             <a:extLst xmlns:a="http://schemas.openxmlformats.org/drawingml/2006/main">
               <a:ext uri="{FF2B5EF4-FFF2-40B4-BE49-F238E27FC236}">
-                <a16:creationId xmlns:a16="http://schemas.microsoft.com/office/drawing/2014/main" id="{E50765EF-77DD-4C13-A78E-A2A5AEC0ACFA}"/>
+                <a16:creationId xmlns:a16="http://schemas.microsoft.com/office/drawing/2014/main" id="{BABA83AF-2589-4BF4-9756-0FBEE9B2BFBF}"/>
               </a:ext>
             </a:extLst>
           </p:cNvPr>
@@ -2029,7 +2029,7 @@
           <p:cNvPr id="4" name="">
             <a:extLst xmlns:a="http://schemas.openxmlformats.org/drawingml/2006/main">
               <a:ext uri="{FF2B5EF4-FFF2-40B4-BE49-F238E27FC236}">
-                <a16:creationId xmlns:a16="http://schemas.microsoft.com/office/drawing/2014/main" id="{57155E6B-8653-48B2-AE2B-3FCEFAC206D4}"/>
+                <a16:creationId xmlns:a16="http://schemas.microsoft.com/office/drawing/2014/main" id="{C3AD687F-5BB4-432C-951D-8AB92EF5B4A4}"/>
               </a:ext>
             </a:extLst>
           </p:cNvPr>
@@ -2086,7 +2086,7 @@
           <p:cNvPr id="5" name="">
             <a:extLst xmlns:a="http://schemas.openxmlformats.org/drawingml/2006/main">
               <a:ext uri="{FF2B5EF4-FFF2-40B4-BE49-F238E27FC236}">
-                <a16:creationId xmlns:a16="http://schemas.microsoft.com/office/drawing/2014/main" id="{75C07369-BBBE-45AC-A447-5550C0C78C48}"/>
+                <a16:creationId xmlns:a16="http://schemas.microsoft.com/office/drawing/2014/main" id="{738DC314-421F-4715-B48B-99B29A0E8416}"/>
               </a:ext>
             </a:extLst>
           </p:cNvPr>
@@ -2143,7 +2143,7 @@
           <p:cNvPr id="6" name="">
             <a:extLst xmlns:a="http://schemas.openxmlformats.org/drawingml/2006/main">
               <a:ext uri="{FF2B5EF4-FFF2-40B4-BE49-F238E27FC236}">
-                <a16:creationId xmlns:a16="http://schemas.microsoft.com/office/drawing/2014/main" id="{3B7A248B-1DAA-4308-B597-FA16FF285D27}"/>
+                <a16:creationId xmlns:a16="http://schemas.microsoft.com/office/drawing/2014/main" id="{CD81D197-3809-4A18-ADEA-5414853AC6CA}"/>
               </a:ext>
             </a:extLst>
           </p:cNvPr>
@@ -2200,7 +2200,7 @@
           <p:cNvPr id="7" name="">
             <a:extLst xmlns:a="http://schemas.openxmlformats.org/drawingml/2006/main">
               <a:ext uri="{FF2B5EF4-FFF2-40B4-BE49-F238E27FC236}">
-                <a16:creationId xmlns:a16="http://schemas.microsoft.com/office/drawing/2014/main" id="{111A2724-57B4-4380-B157-7DFC1AF30554}"/>
+                <a16:creationId xmlns:a16="http://schemas.microsoft.com/office/drawing/2014/main" id="{DA639B7E-150D-4218-845A-EAF18B0FEF0C}"/>
               </a:ext>
             </a:extLst>
           </p:cNvPr>
@@ -2230,7 +2230,7 @@
           <p:cNvPr id="8" name="">
             <a:extLst xmlns:a="http://schemas.openxmlformats.org/drawingml/2006/main">
               <a:ext uri="{FF2B5EF4-FFF2-40B4-BE49-F238E27FC236}">
-                <a16:creationId xmlns:a16="http://schemas.microsoft.com/office/drawing/2014/main" id="{E124E2EC-BC8D-4100-A8B9-A24574D74CDA}"/>
+                <a16:creationId xmlns:a16="http://schemas.microsoft.com/office/drawing/2014/main" id="{8D40C341-D2D9-46C2-9292-5DD3172DDBAF}"/>
               </a:ext>
             </a:extLst>
           </p:cNvPr>
@@ -2287,7 +2287,7 @@
           <p:cNvPr id="9" name="">
             <a:extLst xmlns:a="http://schemas.openxmlformats.org/drawingml/2006/main">
               <a:ext uri="{FF2B5EF4-FFF2-40B4-BE49-F238E27FC236}">
-                <a16:creationId xmlns:a16="http://schemas.microsoft.com/office/drawing/2014/main" id="{05F7C89B-92BB-4731-8A99-9463D3664599}"/>
+                <a16:creationId xmlns:a16="http://schemas.microsoft.com/office/drawing/2014/main" id="{488A91FF-E4D0-4B75-8D01-423A80A174C8}"/>
               </a:ext>
             </a:extLst>
           </p:cNvPr>
@@ -2344,7 +2344,7 @@
           <p:cNvPr id="10" name="">
             <a:extLst xmlns:a="http://schemas.openxmlformats.org/drawingml/2006/main">
               <a:ext uri="{FF2B5EF4-FFF2-40B4-BE49-F238E27FC236}">
-                <a16:creationId xmlns:a16="http://schemas.microsoft.com/office/drawing/2014/main" id="{2C27643C-A02E-4E75-9676-8FC7659A38F2}"/>
+                <a16:creationId xmlns:a16="http://schemas.microsoft.com/office/drawing/2014/main" id="{70CD64A0-F172-48D7-8F3F-7B0772ADB29F}"/>
               </a:ext>
             </a:extLst>
           </p:cNvPr>
@@ -2374,7 +2374,7 @@
           <p:cNvPr id="11" name="">
             <a:extLst xmlns:a="http://schemas.openxmlformats.org/drawingml/2006/main">
               <a:ext uri="{FF2B5EF4-FFF2-40B4-BE49-F238E27FC236}">
-                <a16:creationId xmlns:a16="http://schemas.microsoft.com/office/drawing/2014/main" id="{8F0103FB-E0CD-4982-8D94-139C842EE7BF}"/>
+                <a16:creationId xmlns:a16="http://schemas.microsoft.com/office/drawing/2014/main" id="{5F48C548-AEBC-491D-B0D4-9064E9B7A074}"/>
               </a:ext>
             </a:extLst>
           </p:cNvPr>
@@ -2431,7 +2431,7 @@
           <p:cNvPr id="12" name="">
             <a:extLst xmlns:a="http://schemas.openxmlformats.org/drawingml/2006/main">
               <a:ext uri="{FF2B5EF4-FFF2-40B4-BE49-F238E27FC236}">
-                <a16:creationId xmlns:a16="http://schemas.microsoft.com/office/drawing/2014/main" id="{437673A4-E61A-42F9-ADCD-FC023B8F0AA8}"/>
+                <a16:creationId xmlns:a16="http://schemas.microsoft.com/office/drawing/2014/main" id="{7CBF7FF6-77AD-4FA0-BFF0-0010F9A0BBAF}"/>
               </a:ext>
             </a:extLst>
           </p:cNvPr>
@@ -2486,7 +2486,7 @@
     </p:spTree>
     <p:extLst>
       <p:ext uri="{BB962C8B-B14F-4D97-AF65-F5344CB8AC3E}">
-        <p14:creationId xmlns:p14="http://schemas.microsoft.com/office/powerpoint/2010/main" val="1178660376"/>
+        <p14:creationId xmlns:p14="http://schemas.microsoft.com/office/powerpoint/2010/main" val="1684029618"/>
       </p:ext>
     </p:extLst>
   </p:cSld>
@@ -2517,7 +2517,7 @@
           <p:cNvPr id="11" name="">
             <a:extLst xmlns:a="http://schemas.openxmlformats.org/drawingml/2006/main">
               <a:ext uri="{FF2B5EF4-FFF2-40B4-BE49-F238E27FC236}">
-                <a16:creationId xmlns:a16="http://schemas.microsoft.com/office/drawing/2014/main" id="{ED2B686B-E10B-409A-B1AA-3A2C2F30D687}"/>
+                <a16:creationId xmlns:a16="http://schemas.microsoft.com/office/drawing/2014/main" id="{9DD8F329-5B84-4CCB-87D5-FBDA7232C9BC}"/>
               </a:ext>
             </a:extLst>
           </p:cNvPr>
@@ -2574,7 +2574,7 @@
           <p:cNvPr id="2" name="">
             <a:extLst xmlns:a="http://schemas.openxmlformats.org/drawingml/2006/main">
               <a:ext uri="{FF2B5EF4-FFF2-40B4-BE49-F238E27FC236}">
-                <a16:creationId xmlns:a16="http://schemas.microsoft.com/office/drawing/2014/main" id="{91FF9A9D-CD94-4F99-A322-B728E758B74D}"/>
+                <a16:creationId xmlns:a16="http://schemas.microsoft.com/office/drawing/2014/main" id="{50D4A733-7CFD-4BAD-9EA9-8CB033FE8531}"/>
               </a:ext>
             </a:extLst>
           </p:cNvPr>
@@ -2604,7 +2604,7 @@
           <p:cNvPr id="3" name="">
             <a:extLst xmlns:a="http://schemas.openxmlformats.org/drawingml/2006/main">
               <a:ext uri="{FF2B5EF4-FFF2-40B4-BE49-F238E27FC236}">
-                <a16:creationId xmlns:a16="http://schemas.microsoft.com/office/drawing/2014/main" id="{8F821BC5-54F7-45B6-9A44-259FA0C25B3F}"/>
+                <a16:creationId xmlns:a16="http://schemas.microsoft.com/office/drawing/2014/main" id="{7E1E15C6-A4F8-4927-AE5A-F901640658F1}"/>
               </a:ext>
             </a:extLst>
           </p:cNvPr>
@@ -2661,7 +2661,7 @@
           <p:cNvPr id="4" name="">
             <a:extLst xmlns:a="http://schemas.openxmlformats.org/drawingml/2006/main">
               <a:ext uri="{FF2B5EF4-FFF2-40B4-BE49-F238E27FC236}">
-                <a16:creationId xmlns:a16="http://schemas.microsoft.com/office/drawing/2014/main" id="{098DA73C-EDA9-4AEB-8C94-D69349103CAD}"/>
+                <a16:creationId xmlns:a16="http://schemas.microsoft.com/office/drawing/2014/main" id="{54C09F67-F605-449A-AC8C-A38B9796A31D}"/>
               </a:ext>
             </a:extLst>
           </p:cNvPr>
@@ -2718,7 +2718,7 @@
           <p:cNvPr id="5" name="">
             <a:extLst xmlns:a="http://schemas.openxmlformats.org/drawingml/2006/main">
               <a:ext uri="{FF2B5EF4-FFF2-40B4-BE49-F238E27FC236}">
-                <a16:creationId xmlns:a16="http://schemas.microsoft.com/office/drawing/2014/main" id="{50949684-119B-48FF-B795-D084571FBEF8}"/>
+                <a16:creationId xmlns:a16="http://schemas.microsoft.com/office/drawing/2014/main" id="{4C634888-27D9-41B5-A866-0EB44D3F4B25}"/>
               </a:ext>
             </a:extLst>
           </p:cNvPr>
@@ -2775,7 +2775,7 @@
           <p:cNvPr id="6" name="">
             <a:extLst xmlns:a="http://schemas.openxmlformats.org/drawingml/2006/main">
               <a:ext uri="{FF2B5EF4-FFF2-40B4-BE49-F238E27FC236}">
-                <a16:creationId xmlns:a16="http://schemas.microsoft.com/office/drawing/2014/main" id="{DCE7C3A3-1EF2-48C5-B188-8E5C90D82C3C}"/>
+                <a16:creationId xmlns:a16="http://schemas.microsoft.com/office/drawing/2014/main" id="{40C4D35E-6093-42CF-8235-4FE5256E17BA}"/>
               </a:ext>
             </a:extLst>
           </p:cNvPr>
@@ -2855,7 +2855,7 @@
           <p:cNvPr id="7" name="">
             <a:extLst xmlns:a="http://schemas.openxmlformats.org/drawingml/2006/main">
               <a:ext uri="{FF2B5EF4-FFF2-40B4-BE49-F238E27FC236}">
-                <a16:creationId xmlns:a16="http://schemas.microsoft.com/office/drawing/2014/main" id="{7EFF04AF-08AE-496D-8D04-EA03FE05E412}"/>
+                <a16:creationId xmlns:a16="http://schemas.microsoft.com/office/drawing/2014/main" id="{246325CA-CDF6-48D8-9463-5583F9B6A18A}"/>
               </a:ext>
             </a:extLst>
           </p:cNvPr>
@@ -2912,7 +2912,7 @@
           <p:cNvPr id="8" name="">
             <a:extLst xmlns:a="http://schemas.openxmlformats.org/drawingml/2006/main">
               <a:ext uri="{FF2B5EF4-FFF2-40B4-BE49-F238E27FC236}">
-                <a16:creationId xmlns:a16="http://schemas.microsoft.com/office/drawing/2014/main" id="{1368940E-2C58-4A05-BE80-1FE11C499876}"/>
+                <a16:creationId xmlns:a16="http://schemas.microsoft.com/office/drawing/2014/main" id="{9BE9EDD5-7BBC-4157-9B9D-A0E7C47089AE}"/>
               </a:ext>
             </a:extLst>
           </p:cNvPr>
@@ -2992,7 +2992,7 @@
           <p:cNvPr id="9" name="">
             <a:extLst xmlns:a="http://schemas.openxmlformats.org/drawingml/2006/main">
               <a:ext uri="{FF2B5EF4-FFF2-40B4-BE49-F238E27FC236}">
-                <a16:creationId xmlns:a16="http://schemas.microsoft.com/office/drawing/2014/main" id="{EBCA906A-3716-45A7-8249-E69F9668FEDC}"/>
+                <a16:creationId xmlns:a16="http://schemas.microsoft.com/office/drawing/2014/main" id="{24963B2C-BB58-4C8A-91D2-1AC43477F0B3}"/>
               </a:ext>
             </a:extLst>
           </p:cNvPr>
@@ -3022,7 +3022,7 @@
           <p:cNvPr id="10" name="">
             <a:extLst xmlns:a="http://schemas.openxmlformats.org/drawingml/2006/main">
               <a:ext uri="{FF2B5EF4-FFF2-40B4-BE49-F238E27FC236}">
-                <a16:creationId xmlns:a16="http://schemas.microsoft.com/office/drawing/2014/main" id="{E4B89D0F-FAA1-4212-9CBF-D930C0A510E4}"/>
+                <a16:creationId xmlns:a16="http://schemas.microsoft.com/office/drawing/2014/main" id="{E7C24AA9-33C9-4F9B-AF6B-4D646E043826}"/>
               </a:ext>
             </a:extLst>
           </p:cNvPr>
@@ -3077,7 +3077,7 @@
     </p:spTree>
     <p:extLst>
       <p:ext uri="{BB962C8B-B14F-4D97-AF65-F5344CB8AC3E}">
-        <p14:creationId xmlns:p14="http://schemas.microsoft.com/office/powerpoint/2010/main" val="1108552135"/>
+        <p14:creationId xmlns:p14="http://schemas.microsoft.com/office/powerpoint/2010/main" val="1045917696"/>
       </p:ext>
     </p:extLst>
   </p:cSld>
@@ -3108,7 +3108,7 @@
           <p:cNvPr id="16" name="">
             <a:extLst xmlns:a="http://schemas.openxmlformats.org/drawingml/2006/main">
               <a:ext uri="{FF2B5EF4-FFF2-40B4-BE49-F238E27FC236}">
-                <a16:creationId xmlns:a16="http://schemas.microsoft.com/office/drawing/2014/main" id="{2A01D6FB-8D1A-4A97-8178-8459744DD3E8}"/>
+                <a16:creationId xmlns:a16="http://schemas.microsoft.com/office/drawing/2014/main" id="{F17459C6-BC80-48C3-AEDD-48575F9C13D7}"/>
               </a:ext>
             </a:extLst>
           </p:cNvPr>
@@ -3165,7 +3165,7 @@
           <p:cNvPr id="2" name="">
             <a:extLst xmlns:a="http://schemas.openxmlformats.org/drawingml/2006/main">
               <a:ext uri="{FF2B5EF4-FFF2-40B4-BE49-F238E27FC236}">
-                <a16:creationId xmlns:a16="http://schemas.microsoft.com/office/drawing/2014/main" id="{F2848A6C-B810-44E7-9562-8B00E786A22E}"/>
+                <a16:creationId xmlns:a16="http://schemas.microsoft.com/office/drawing/2014/main" id="{0006CE77-DCE2-48BA-9D6C-89B9A29E8B8E}"/>
               </a:ext>
             </a:extLst>
           </p:cNvPr>
@@ -3195,7 +3195,7 @@
           <p:cNvPr id="3" name="">
             <a:extLst xmlns:a="http://schemas.openxmlformats.org/drawingml/2006/main">
               <a:ext uri="{FF2B5EF4-FFF2-40B4-BE49-F238E27FC236}">
-                <a16:creationId xmlns:a16="http://schemas.microsoft.com/office/drawing/2014/main" id="{3B98B0CB-D7DE-497F-BBC9-28818D1F9AA6}"/>
+                <a16:creationId xmlns:a16="http://schemas.microsoft.com/office/drawing/2014/main" id="{BBB0D75D-1862-404A-B943-FA6760041464}"/>
               </a:ext>
             </a:extLst>
           </p:cNvPr>
@@ -3252,7 +3252,7 @@
           <p:cNvPr id="4" name="">
             <a:extLst xmlns:a="http://schemas.openxmlformats.org/drawingml/2006/main">
               <a:ext uri="{FF2B5EF4-FFF2-40B4-BE49-F238E27FC236}">
-                <a16:creationId xmlns:a16="http://schemas.microsoft.com/office/drawing/2014/main" id="{F95233EB-B201-4EC5-8B52-4A2D54A0CDBD}"/>
+                <a16:creationId xmlns:a16="http://schemas.microsoft.com/office/drawing/2014/main" id="{71E3D22D-1A10-4C78-BE54-611F15CCAC7B}"/>
               </a:ext>
             </a:extLst>
           </p:cNvPr>
@@ -3309,7 +3309,7 @@
           <p:cNvPr id="5" name="">
             <a:extLst xmlns:a="http://schemas.openxmlformats.org/drawingml/2006/main">
               <a:ext uri="{FF2B5EF4-FFF2-40B4-BE49-F238E27FC236}">
-                <a16:creationId xmlns:a16="http://schemas.microsoft.com/office/drawing/2014/main" id="{F0E231EA-2AFB-4BBE-A844-8B1BE7450815}"/>
+                <a16:creationId xmlns:a16="http://schemas.microsoft.com/office/drawing/2014/main" id="{22DBCCB2-5FC8-44E1-BE43-ED7C1601B506}"/>
               </a:ext>
             </a:extLst>
           </p:cNvPr>
@@ -3366,7 +3366,7 @@
           <p:cNvPr id="6" name="">
             <a:extLst xmlns:a="http://schemas.openxmlformats.org/drawingml/2006/main">
               <a:ext uri="{FF2B5EF4-FFF2-40B4-BE49-F238E27FC236}">
-                <a16:creationId xmlns:a16="http://schemas.microsoft.com/office/drawing/2014/main" id="{D08CAE02-927A-40BB-8954-92AA41E6C0F5}"/>
+                <a16:creationId xmlns:a16="http://schemas.microsoft.com/office/drawing/2014/main" id="{6FE1FF39-5D38-46D0-8AAF-F0A20B108328}"/>
               </a:ext>
             </a:extLst>
           </p:cNvPr>
@@ -3423,7 +3423,7 @@
           <p:cNvPr id="7" name="">
             <a:extLst xmlns:a="http://schemas.openxmlformats.org/drawingml/2006/main">
               <a:ext uri="{FF2B5EF4-FFF2-40B4-BE49-F238E27FC236}">
-                <a16:creationId xmlns:a16="http://schemas.microsoft.com/office/drawing/2014/main" id="{6AFDAD9A-2D2A-42FD-ACA9-066662714FE4}"/>
+                <a16:creationId xmlns:a16="http://schemas.microsoft.com/office/drawing/2014/main" id="{3606AC51-918F-490D-8DF7-CDFC494CC8E6}"/>
               </a:ext>
             </a:extLst>
           </p:cNvPr>
@@ -3453,7 +3453,7 @@
           <p:cNvPr id="8" name="">
             <a:extLst xmlns:a="http://schemas.openxmlformats.org/drawingml/2006/main">
               <a:ext uri="{FF2B5EF4-FFF2-40B4-BE49-F238E27FC236}">
-                <a16:creationId xmlns:a16="http://schemas.microsoft.com/office/drawing/2014/main" id="{F763CDBD-E36F-42AE-BB0C-3DC535E8A63B}"/>
+                <a16:creationId xmlns:a16="http://schemas.microsoft.com/office/drawing/2014/main" id="{1C021FD0-089A-405A-B7E4-A03030EF959C}"/>
               </a:ext>
             </a:extLst>
           </p:cNvPr>
@@ -3510,7 +3510,7 @@
           <p:cNvPr id="9" name="">
             <a:extLst xmlns:a="http://schemas.openxmlformats.org/drawingml/2006/main">
               <a:ext uri="{FF2B5EF4-FFF2-40B4-BE49-F238E27FC236}">
-                <a16:creationId xmlns:a16="http://schemas.microsoft.com/office/drawing/2014/main" id="{545BA4C7-B5F8-4F0D-BC04-62989E4D39B0}"/>
+                <a16:creationId xmlns:a16="http://schemas.microsoft.com/office/drawing/2014/main" id="{4FF12E04-4A55-4865-A6E5-109896E5B453}"/>
               </a:ext>
             </a:extLst>
           </p:cNvPr>
@@ -3567,7 +3567,7 @@
           <p:cNvPr id="10" name="">
             <a:extLst xmlns:a="http://schemas.openxmlformats.org/drawingml/2006/main">
               <a:ext uri="{FF2B5EF4-FFF2-40B4-BE49-F238E27FC236}">
-                <a16:creationId xmlns:a16="http://schemas.microsoft.com/office/drawing/2014/main" id="{EFECDF06-D4B9-42AF-834E-A4281C44872D}"/>
+                <a16:creationId xmlns:a16="http://schemas.microsoft.com/office/drawing/2014/main" id="{DC1F6637-F1EF-4179-84F3-B1F163904A6C}"/>
               </a:ext>
             </a:extLst>
           </p:cNvPr>
@@ -3597,7 +3597,7 @@
           <p:cNvPr id="11" name="">
             <a:extLst xmlns:a="http://schemas.openxmlformats.org/drawingml/2006/main">
               <a:ext uri="{FF2B5EF4-FFF2-40B4-BE49-F238E27FC236}">
-                <a16:creationId xmlns:a16="http://schemas.microsoft.com/office/drawing/2014/main" id="{21B20C77-B99E-453F-8A69-9BB8D9CBAC95}"/>
+                <a16:creationId xmlns:a16="http://schemas.microsoft.com/office/drawing/2014/main" id="{EE478A9C-3CFD-46F0-945D-9C5CB2EDA639}"/>
               </a:ext>
             </a:extLst>
           </p:cNvPr>
@@ -3654,7 +3654,7 @@
           <p:cNvPr id="12" name="">
             <a:extLst xmlns:a="http://schemas.openxmlformats.org/drawingml/2006/main">
               <a:ext uri="{FF2B5EF4-FFF2-40B4-BE49-F238E27FC236}">
-                <a16:creationId xmlns:a16="http://schemas.microsoft.com/office/drawing/2014/main" id="{A749AFDA-3407-43AE-91F9-C5A8833732AA}"/>
+                <a16:creationId xmlns:a16="http://schemas.microsoft.com/office/drawing/2014/main" id="{2A6BD450-13D5-4C9A-9460-8DB627E2DC98}"/>
               </a:ext>
             </a:extLst>
           </p:cNvPr>
@@ -3711,7 +3711,7 @@
           <p:cNvPr id="13" name="">
             <a:extLst xmlns:a="http://schemas.openxmlformats.org/drawingml/2006/main">
               <a:ext uri="{FF2B5EF4-FFF2-40B4-BE49-F238E27FC236}">
-                <a16:creationId xmlns:a16="http://schemas.microsoft.com/office/drawing/2014/main" id="{A72D99A8-618D-4A2A-9DB2-453433EEE01A}"/>
+                <a16:creationId xmlns:a16="http://schemas.microsoft.com/office/drawing/2014/main" id="{15BC1321-0EEA-4A85-B5F9-ABF0BCC0BEFD}"/>
               </a:ext>
             </a:extLst>
           </p:cNvPr>
@@ -3741,7 +3741,7 @@
           <p:cNvPr id="14" name="">
             <a:extLst xmlns:a="http://schemas.openxmlformats.org/drawingml/2006/main">
               <a:ext uri="{FF2B5EF4-FFF2-40B4-BE49-F238E27FC236}">
-                <a16:creationId xmlns:a16="http://schemas.microsoft.com/office/drawing/2014/main" id="{4A18AD96-376C-49D1-9AE4-62917B08C5AE}"/>
+                <a16:creationId xmlns:a16="http://schemas.microsoft.com/office/drawing/2014/main" id="{A405165F-B09D-4293-A830-A8FFD88AF20F}"/>
               </a:ext>
             </a:extLst>
           </p:cNvPr>
@@ -3798,7 +3798,7 @@
           <p:cNvPr id="15" name="">
             <a:extLst xmlns:a="http://schemas.openxmlformats.org/drawingml/2006/main">
               <a:ext uri="{FF2B5EF4-FFF2-40B4-BE49-F238E27FC236}">
-                <a16:creationId xmlns:a16="http://schemas.microsoft.com/office/drawing/2014/main" id="{ECE3129F-CDB2-4826-AD86-CA9660D2F8E1}"/>
+                <a16:creationId xmlns:a16="http://schemas.microsoft.com/office/drawing/2014/main" id="{10E31D6E-0222-4D19-97DA-50D21640C7F0}"/>
               </a:ext>
             </a:extLst>
           </p:cNvPr>
@@ -3853,7 +3853,7 @@
     </p:spTree>
     <p:extLst>
       <p:ext uri="{BB962C8B-B14F-4D97-AF65-F5344CB8AC3E}">
-        <p14:creationId xmlns:p14="http://schemas.microsoft.com/office/powerpoint/2010/main" val="32746763"/>
+        <p14:creationId xmlns:p14="http://schemas.microsoft.com/office/powerpoint/2010/main" val="269706644"/>
       </p:ext>
     </p:extLst>
   </p:cSld>
@@ -3884,7 +3884,7 @@
           <p:cNvPr id="11" name="">
             <a:extLst xmlns:a="http://schemas.openxmlformats.org/drawingml/2006/main">
               <a:ext uri="{FF2B5EF4-FFF2-40B4-BE49-F238E27FC236}">
-                <a16:creationId xmlns:a16="http://schemas.microsoft.com/office/drawing/2014/main" id="{F3A1E128-027D-4F68-9751-9BC1ACF29F09}"/>
+                <a16:creationId xmlns:a16="http://schemas.microsoft.com/office/drawing/2014/main" id="{960C0229-D74C-4F8E-94ED-6FB7C6C955FF}"/>
               </a:ext>
             </a:extLst>
           </p:cNvPr>
@@ -3941,7 +3941,7 @@
           <p:cNvPr id="2" name="">
             <a:extLst xmlns:a="http://schemas.openxmlformats.org/drawingml/2006/main">
               <a:ext uri="{FF2B5EF4-FFF2-40B4-BE49-F238E27FC236}">
-                <a16:creationId xmlns:a16="http://schemas.microsoft.com/office/drawing/2014/main" id="{F29E6D46-6BDA-4BA2-B1BF-44E82F688238}"/>
+                <a16:creationId xmlns:a16="http://schemas.microsoft.com/office/drawing/2014/main" id="{7D00A51B-36AD-4B87-92F3-6E26FF90DBE7}"/>
               </a:ext>
             </a:extLst>
           </p:cNvPr>
@@ -3971,7 +3971,7 @@
           <p:cNvPr id="3" name="">
             <a:extLst xmlns:a="http://schemas.openxmlformats.org/drawingml/2006/main">
               <a:ext uri="{FF2B5EF4-FFF2-40B4-BE49-F238E27FC236}">
-                <a16:creationId xmlns:a16="http://schemas.microsoft.com/office/drawing/2014/main" id="{4A8AE095-9C9F-4779-BAA8-673B1818D31A}"/>
+                <a16:creationId xmlns:a16="http://schemas.microsoft.com/office/drawing/2014/main" id="{0E9E78F4-D220-4592-B5B3-2B2F370B8EEF}"/>
               </a:ext>
             </a:extLst>
           </p:cNvPr>
@@ -4028,7 +4028,7 @@
           <p:cNvPr id="4" name="">
             <a:extLst xmlns:a="http://schemas.openxmlformats.org/drawingml/2006/main">
               <a:ext uri="{FF2B5EF4-FFF2-40B4-BE49-F238E27FC236}">
-                <a16:creationId xmlns:a16="http://schemas.microsoft.com/office/drawing/2014/main" id="{2DD44E2C-D91B-43A4-B36D-4F01C925ACA9}"/>
+                <a16:creationId xmlns:a16="http://schemas.microsoft.com/office/drawing/2014/main" id="{AD470A88-C3E9-47B7-8A88-71B949EE5639}"/>
               </a:ext>
             </a:extLst>
           </p:cNvPr>
@@ -4085,7 +4085,7 @@
           <p:cNvPr id="5" name="">
             <a:extLst xmlns:a="http://schemas.openxmlformats.org/drawingml/2006/main">
               <a:ext uri="{FF2B5EF4-FFF2-40B4-BE49-F238E27FC236}">
-                <a16:creationId xmlns:a16="http://schemas.microsoft.com/office/drawing/2014/main" id="{BB3C68F5-8AD7-4A65-8E58-6815EB8C90AF}"/>
+                <a16:creationId xmlns:a16="http://schemas.microsoft.com/office/drawing/2014/main" id="{5571D6D4-6DA3-44A2-B89B-D7520A0C5881}"/>
               </a:ext>
             </a:extLst>
           </p:cNvPr>
@@ -4142,7 +4142,7 @@
           <p:cNvPr id="6" name="">
             <a:extLst xmlns:a="http://schemas.openxmlformats.org/drawingml/2006/main">
               <a:ext uri="{FF2B5EF4-FFF2-40B4-BE49-F238E27FC236}">
-                <a16:creationId xmlns:a16="http://schemas.microsoft.com/office/drawing/2014/main" id="{C65F0BB8-065C-4034-8789-5CAFBFD2934B}"/>
+                <a16:creationId xmlns:a16="http://schemas.microsoft.com/office/drawing/2014/main" id="{EC719C36-77E9-4C42-8980-967AF436ECD4}"/>
               </a:ext>
             </a:extLst>
           </p:cNvPr>
@@ -4199,7 +4199,7 @@
           <p:cNvPr id="7" name="">
             <a:extLst xmlns:a="http://schemas.openxmlformats.org/drawingml/2006/main">
               <a:ext uri="{FF2B5EF4-FFF2-40B4-BE49-F238E27FC236}">
-                <a16:creationId xmlns:a16="http://schemas.microsoft.com/office/drawing/2014/main" id="{1EE19C6B-8D4A-46A8-8EB5-284D8A90C0DA}"/>
+                <a16:creationId xmlns:a16="http://schemas.microsoft.com/office/drawing/2014/main" id="{0BDB4557-C30F-439C-A34F-FB862CE3BB6B}"/>
               </a:ext>
             </a:extLst>
           </p:cNvPr>
@@ -4229,7 +4229,7 @@
           <p:cNvPr id="8" name="">
             <a:extLst xmlns:a="http://schemas.openxmlformats.org/drawingml/2006/main">
               <a:ext uri="{FF2B5EF4-FFF2-40B4-BE49-F238E27FC236}">
-                <a16:creationId xmlns:a16="http://schemas.microsoft.com/office/drawing/2014/main" id="{E4C941DA-043F-4BD3-B459-1F668841BE11}"/>
+                <a16:creationId xmlns:a16="http://schemas.microsoft.com/office/drawing/2014/main" id="{078C7D8B-8AF5-44AE-BDA9-EB4123FC6E18}"/>
               </a:ext>
             </a:extLst>
           </p:cNvPr>
@@ -4286,7 +4286,7 @@
           <p:cNvPr id="9" name="">
             <a:extLst xmlns:a="http://schemas.openxmlformats.org/drawingml/2006/main">
               <a:ext uri="{FF2B5EF4-FFF2-40B4-BE49-F238E27FC236}">
-                <a16:creationId xmlns:a16="http://schemas.microsoft.com/office/drawing/2014/main" id="{7FAC9D92-C833-4731-AA89-662949A7ED42}"/>
+                <a16:creationId xmlns:a16="http://schemas.microsoft.com/office/drawing/2014/main" id="{F7AF175C-F14F-4F64-A34E-7A4D40AD5294}"/>
               </a:ext>
             </a:extLst>
           </p:cNvPr>
@@ -4343,7 +4343,7 @@
           <p:cNvPr id="10" name="">
             <a:extLst xmlns:a="http://schemas.openxmlformats.org/drawingml/2006/main">
               <a:ext uri="{FF2B5EF4-FFF2-40B4-BE49-F238E27FC236}">
-                <a16:creationId xmlns:a16="http://schemas.microsoft.com/office/drawing/2014/main" id="{498F3A32-02E0-409F-B660-47B5FD45EE5E}"/>
+                <a16:creationId xmlns:a16="http://schemas.microsoft.com/office/drawing/2014/main" id="{C0B2369A-FA39-405B-8B2B-06A288B4A676}"/>
               </a:ext>
             </a:extLst>
           </p:cNvPr>
@@ -4398,7 +4398,7 @@
     </p:spTree>
     <p:extLst>
       <p:ext uri="{BB962C8B-B14F-4D97-AF65-F5344CB8AC3E}">
-        <p14:creationId xmlns:p14="http://schemas.microsoft.com/office/powerpoint/2010/main" val="38859651"/>
+        <p14:creationId xmlns:p14="http://schemas.microsoft.com/office/powerpoint/2010/main" val="849219897"/>
       </p:ext>
     </p:extLst>
   </p:cSld>
@@ -4429,7 +4429,7 @@
           <p:cNvPr id="14" name="">
             <a:extLst xmlns:a="http://schemas.openxmlformats.org/drawingml/2006/main">
               <a:ext uri="{FF2B5EF4-FFF2-40B4-BE49-F238E27FC236}">
-                <a16:creationId xmlns:a16="http://schemas.microsoft.com/office/drawing/2014/main" id="{50303B8B-DAD1-42C2-B69B-A9E0A2A305C0}"/>
+                <a16:creationId xmlns:a16="http://schemas.microsoft.com/office/drawing/2014/main" id="{53F7D6B7-9BBA-4A69-9209-BEFE7022F2FD}"/>
               </a:ext>
             </a:extLst>
           </p:cNvPr>
@@ -4486,7 +4486,7 @@
           <p:cNvPr id="2" name="">
             <a:extLst xmlns:a="http://schemas.openxmlformats.org/drawingml/2006/main">
               <a:ext uri="{FF2B5EF4-FFF2-40B4-BE49-F238E27FC236}">
-                <a16:creationId xmlns:a16="http://schemas.microsoft.com/office/drawing/2014/main" id="{FD5D8CC1-B2ED-44E4-A618-898CD98C1690}"/>
+                <a16:creationId xmlns:a16="http://schemas.microsoft.com/office/drawing/2014/main" id="{8D19C1FD-AE12-41E2-8396-F81AB325962C}"/>
               </a:ext>
             </a:extLst>
           </p:cNvPr>
@@ -4516,7 +4516,7 @@
           <p:cNvPr id="3" name="">
             <a:extLst xmlns:a="http://schemas.openxmlformats.org/drawingml/2006/main">
               <a:ext uri="{FF2B5EF4-FFF2-40B4-BE49-F238E27FC236}">
-                <a16:creationId xmlns:a16="http://schemas.microsoft.com/office/drawing/2014/main" id="{F045230F-FF7E-4E36-9903-81104763AA78}"/>
+                <a16:creationId xmlns:a16="http://schemas.microsoft.com/office/drawing/2014/main" id="{8875D0FF-653B-44F7-8E7D-F5DD48C9F69A}"/>
               </a:ext>
             </a:extLst>
           </p:cNvPr>
@@ -4573,7 +4573,7 @@
           <p:cNvPr id="4" name="">
             <a:extLst xmlns:a="http://schemas.openxmlformats.org/drawingml/2006/main">
               <a:ext uri="{FF2B5EF4-FFF2-40B4-BE49-F238E27FC236}">
-                <a16:creationId xmlns:a16="http://schemas.microsoft.com/office/drawing/2014/main" id="{A83391F8-67A4-4CDB-939D-F80F72C97CA1}"/>
+                <a16:creationId xmlns:a16="http://schemas.microsoft.com/office/drawing/2014/main" id="{580D97D7-8D3A-446D-8538-A291C3B27100}"/>
               </a:ext>
             </a:extLst>
           </p:cNvPr>
@@ -4630,7 +4630,7 @@
           <p:cNvPr id="5" name="">
             <a:extLst xmlns:a="http://schemas.openxmlformats.org/drawingml/2006/main">
               <a:ext uri="{FF2B5EF4-FFF2-40B4-BE49-F238E27FC236}">
-                <a16:creationId xmlns:a16="http://schemas.microsoft.com/office/drawing/2014/main" id="{DA6DDCEA-0083-4991-9023-AF63D318F9D4}"/>
+                <a16:creationId xmlns:a16="http://schemas.microsoft.com/office/drawing/2014/main" id="{56F8DFB0-92C0-4004-8984-9137C04B4652}"/>
               </a:ext>
             </a:extLst>
           </p:cNvPr>
@@ -4687,7 +4687,7 @@
           <p:cNvPr id="6" name="">
             <a:extLst xmlns:a="http://schemas.openxmlformats.org/drawingml/2006/main">
               <a:ext uri="{FF2B5EF4-FFF2-40B4-BE49-F238E27FC236}">
-                <a16:creationId xmlns:a16="http://schemas.microsoft.com/office/drawing/2014/main" id="{F449F940-5BC9-444A-BBBB-C6DDEBA99894}"/>
+                <a16:creationId xmlns:a16="http://schemas.microsoft.com/office/drawing/2014/main" id="{8E2329FC-82F3-423E-8EB0-9AA92C3F3B87}"/>
               </a:ext>
             </a:extLst>
           </p:cNvPr>
@@ -4744,7 +4744,7 @@
           <p:cNvPr id="7" name="">
             <a:extLst xmlns:a="http://schemas.openxmlformats.org/drawingml/2006/main">
               <a:ext uri="{FF2B5EF4-FFF2-40B4-BE49-F238E27FC236}">
-                <a16:creationId xmlns:a16="http://schemas.microsoft.com/office/drawing/2014/main" id="{0F4F1A28-BB2A-4443-ACC5-03BE5FD5C304}"/>
+                <a16:creationId xmlns:a16="http://schemas.microsoft.com/office/drawing/2014/main" id="{4FAE46FC-3CD2-4F7B-A38A-4758B50A93B9}"/>
               </a:ext>
             </a:extLst>
           </p:cNvPr>
@@ -4801,7 +4801,7 @@
           <p:cNvPr id="8" name="">
             <a:extLst xmlns:a="http://schemas.openxmlformats.org/drawingml/2006/main">
               <a:ext uri="{FF2B5EF4-FFF2-40B4-BE49-F238E27FC236}">
-                <a16:creationId xmlns:a16="http://schemas.microsoft.com/office/drawing/2014/main" id="{E51FC14F-2024-4B8B-8C70-06CDF0EA7404}"/>
+                <a16:creationId xmlns:a16="http://schemas.microsoft.com/office/drawing/2014/main" id="{815EA23A-710B-4635-9A30-E1631C8BC0B1}"/>
               </a:ext>
             </a:extLst>
           </p:cNvPr>
@@ -4858,7 +4858,7 @@
           <p:cNvPr id="9" name="">
             <a:extLst xmlns:a="http://schemas.openxmlformats.org/drawingml/2006/main">
               <a:ext uri="{FF2B5EF4-FFF2-40B4-BE49-F238E27FC236}">
-                <a16:creationId xmlns:a16="http://schemas.microsoft.com/office/drawing/2014/main" id="{4D66EF31-9988-4007-9368-B2B4159A2D0F}"/>
+                <a16:creationId xmlns:a16="http://schemas.microsoft.com/office/drawing/2014/main" id="{CCEFA5D5-83DB-4A25-B23F-CAB71BCD21B9}"/>
               </a:ext>
             </a:extLst>
           </p:cNvPr>
@@ -4888,7 +4888,7 @@
           <p:cNvPr id="10" name="">
             <a:extLst xmlns:a="http://schemas.openxmlformats.org/drawingml/2006/main">
               <a:ext uri="{FF2B5EF4-FFF2-40B4-BE49-F238E27FC236}">
-                <a16:creationId xmlns:a16="http://schemas.microsoft.com/office/drawing/2014/main" id="{15788366-B2D4-46DE-8B25-F25D94603135}"/>
+                <a16:creationId xmlns:a16="http://schemas.microsoft.com/office/drawing/2014/main" id="{5DCEEFCF-9562-4648-A827-E2D4C732AF88}"/>
               </a:ext>
             </a:extLst>
           </p:cNvPr>
@@ -4945,7 +4945,7 @@
           <p:cNvPr id="11" name="">
             <a:extLst xmlns:a="http://schemas.openxmlformats.org/drawingml/2006/main">
               <a:ext uri="{FF2B5EF4-FFF2-40B4-BE49-F238E27FC236}">
-                <a16:creationId xmlns:a16="http://schemas.microsoft.com/office/drawing/2014/main" id="{24677404-D3BE-41D2-8D1D-82D44B943B1E}"/>
+                <a16:creationId xmlns:a16="http://schemas.microsoft.com/office/drawing/2014/main" id="{6F2359DE-C177-45F7-9F8D-86D9561834AD}"/>
               </a:ext>
             </a:extLst>
           </p:cNvPr>
@@ -5002,7 +5002,7 @@
           <p:cNvPr id="12" name="">
             <a:extLst xmlns:a="http://schemas.openxmlformats.org/drawingml/2006/main">
               <a:ext uri="{FF2B5EF4-FFF2-40B4-BE49-F238E27FC236}">
-                <a16:creationId xmlns:a16="http://schemas.microsoft.com/office/drawing/2014/main" id="{E244A03E-185E-4C51-985D-6E74D112DA47}"/>
+                <a16:creationId xmlns:a16="http://schemas.microsoft.com/office/drawing/2014/main" id="{F3FF0549-D215-4969-8F3A-FB9C1E6E6CB3}"/>
               </a:ext>
             </a:extLst>
           </p:cNvPr>
@@ -5059,7 +5059,7 @@
           <p:cNvPr id="13" name="">
             <a:extLst xmlns:a="http://schemas.openxmlformats.org/drawingml/2006/main">
               <a:ext uri="{FF2B5EF4-FFF2-40B4-BE49-F238E27FC236}">
-                <a16:creationId xmlns:a16="http://schemas.microsoft.com/office/drawing/2014/main" id="{E5206181-178B-4D97-9FA3-427AD64779B8}"/>
+                <a16:creationId xmlns:a16="http://schemas.microsoft.com/office/drawing/2014/main" id="{ADA1DC4F-A44E-4F79-AA4B-4D3C42EF75BA}"/>
               </a:ext>
             </a:extLst>
           </p:cNvPr>
@@ -5114,7 +5114,7 @@
     </p:spTree>
     <p:extLst>
       <p:ext uri="{BB962C8B-B14F-4D97-AF65-F5344CB8AC3E}">
-        <p14:creationId xmlns:p14="http://schemas.microsoft.com/office/powerpoint/2010/main" val="503064892"/>
+        <p14:creationId xmlns:p14="http://schemas.microsoft.com/office/powerpoint/2010/main" val="1669854593"/>
       </p:ext>
     </p:extLst>
   </p:cSld>
@@ -5145,7 +5145,7 @@
           <p:cNvPr id="13" name="">
             <a:extLst xmlns:a="http://schemas.openxmlformats.org/drawingml/2006/main">
               <a:ext uri="{FF2B5EF4-FFF2-40B4-BE49-F238E27FC236}">
-                <a16:creationId xmlns:a16="http://schemas.microsoft.com/office/drawing/2014/main" id="{325B0E81-3315-4C72-82B7-2BF46F921C23}"/>
+                <a16:creationId xmlns:a16="http://schemas.microsoft.com/office/drawing/2014/main" id="{E395A069-2AC0-45B7-B585-22FC8979C11E}"/>
               </a:ext>
             </a:extLst>
           </p:cNvPr>
@@ -5202,7 +5202,7 @@
           <p:cNvPr id="2" name="">
             <a:extLst xmlns:a="http://schemas.openxmlformats.org/drawingml/2006/main">
               <a:ext uri="{FF2B5EF4-FFF2-40B4-BE49-F238E27FC236}">
-                <a16:creationId xmlns:a16="http://schemas.microsoft.com/office/drawing/2014/main" id="{45E3CB4D-4399-41A9-9462-4CF8E40F3FD4}"/>
+                <a16:creationId xmlns:a16="http://schemas.microsoft.com/office/drawing/2014/main" id="{0A8C1030-6BF8-453F-B558-C026840EE87F}"/>
               </a:ext>
             </a:extLst>
           </p:cNvPr>
@@ -5232,7 +5232,7 @@
           <p:cNvPr id="3" name="">
             <a:extLst xmlns:a="http://schemas.openxmlformats.org/drawingml/2006/main">
               <a:ext uri="{FF2B5EF4-FFF2-40B4-BE49-F238E27FC236}">
-                <a16:creationId xmlns:a16="http://schemas.microsoft.com/office/drawing/2014/main" id="{DA35EB63-37B8-422D-8643-B79F213916DD}"/>
+                <a16:creationId xmlns:a16="http://schemas.microsoft.com/office/drawing/2014/main" id="{C0B2FC0A-4800-4900-81CA-64CD030775C5}"/>
               </a:ext>
             </a:extLst>
           </p:cNvPr>
@@ -5289,7 +5289,7 @@
           <p:cNvPr id="4" name="">
             <a:extLst xmlns:a="http://schemas.openxmlformats.org/drawingml/2006/main">
               <a:ext uri="{FF2B5EF4-FFF2-40B4-BE49-F238E27FC236}">
-                <a16:creationId xmlns:a16="http://schemas.microsoft.com/office/drawing/2014/main" id="{E207655F-B044-4438-89A0-897BDCD34BD9}"/>
+                <a16:creationId xmlns:a16="http://schemas.microsoft.com/office/drawing/2014/main" id="{C49D0BEA-C0F1-44EE-BDF1-947631A9DBAF}"/>
               </a:ext>
             </a:extLst>
           </p:cNvPr>
@@ -5346,7 +5346,7 @@
           <p:cNvPr id="5" name="">
             <a:extLst xmlns:a="http://schemas.openxmlformats.org/drawingml/2006/main">
               <a:ext uri="{FF2B5EF4-FFF2-40B4-BE49-F238E27FC236}">
-                <a16:creationId xmlns:a16="http://schemas.microsoft.com/office/drawing/2014/main" id="{E0429E9B-2563-4599-95E1-87A969311B95}"/>
+                <a16:creationId xmlns:a16="http://schemas.microsoft.com/office/drawing/2014/main" id="{B39A423F-E991-47A9-9469-650DFBDC725C}"/>
               </a:ext>
             </a:extLst>
           </p:cNvPr>
@@ -5403,7 +5403,7 @@
           <p:cNvPr id="6" name="">
             <a:extLst xmlns:a="http://schemas.openxmlformats.org/drawingml/2006/main">
               <a:ext uri="{FF2B5EF4-FFF2-40B4-BE49-F238E27FC236}">
-                <a16:creationId xmlns:a16="http://schemas.microsoft.com/office/drawing/2014/main" id="{85154781-3A6D-463C-AA9F-F1747802F507}"/>
+                <a16:creationId xmlns:a16="http://schemas.microsoft.com/office/drawing/2014/main" id="{BCFE6C1C-D2A6-47B9-9064-43D7C25E23AC}"/>
               </a:ext>
             </a:extLst>
           </p:cNvPr>
@@ -5460,7 +5460,7 @@
           <p:cNvPr id="7" name="">
             <a:extLst xmlns:a="http://schemas.openxmlformats.org/drawingml/2006/main">
               <a:ext uri="{FF2B5EF4-FFF2-40B4-BE49-F238E27FC236}">
-                <a16:creationId xmlns:a16="http://schemas.microsoft.com/office/drawing/2014/main" id="{7425FECB-104E-4558-BE91-CE0239E5BB3F}"/>
+                <a16:creationId xmlns:a16="http://schemas.microsoft.com/office/drawing/2014/main" id="{E3D97492-8E77-4669-B400-17AC2CBD6390}"/>
               </a:ext>
             </a:extLst>
           </p:cNvPr>
@@ -5490,7 +5490,7 @@
           <p:cNvPr id="8" name="">
             <a:extLst xmlns:a="http://schemas.openxmlformats.org/drawingml/2006/main">
               <a:ext uri="{FF2B5EF4-FFF2-40B4-BE49-F238E27FC236}">
-                <a16:creationId xmlns:a16="http://schemas.microsoft.com/office/drawing/2014/main" id="{A00C842A-2C27-44C3-BFF6-B0FA7B9E54A6}"/>
+                <a16:creationId xmlns:a16="http://schemas.microsoft.com/office/drawing/2014/main" id="{923FCAEB-AC56-454E-B2F2-A6D70968DDC8}"/>
               </a:ext>
             </a:extLst>
           </p:cNvPr>
@@ -5547,7 +5547,7 @@
           <p:cNvPr id="9" name="">
             <a:extLst xmlns:a="http://schemas.openxmlformats.org/drawingml/2006/main">
               <a:ext uri="{FF2B5EF4-FFF2-40B4-BE49-F238E27FC236}">
-                <a16:creationId xmlns:a16="http://schemas.microsoft.com/office/drawing/2014/main" id="{91FF7C23-30F5-4A02-87E0-C7C70A8FE5E6}"/>
+                <a16:creationId xmlns:a16="http://schemas.microsoft.com/office/drawing/2014/main" id="{177D09BB-7999-4141-8FCA-C671FFF3ABA7}"/>
               </a:ext>
             </a:extLst>
           </p:cNvPr>
@@ -5604,7 +5604,7 @@
           <p:cNvPr id="10" name="">
             <a:extLst xmlns:a="http://schemas.openxmlformats.org/drawingml/2006/main">
               <a:ext uri="{FF2B5EF4-FFF2-40B4-BE49-F238E27FC236}">
-                <a16:creationId xmlns:a16="http://schemas.microsoft.com/office/drawing/2014/main" id="{9DEE2296-1443-4285-AB45-E77EE25600D3}"/>
+                <a16:creationId xmlns:a16="http://schemas.microsoft.com/office/drawing/2014/main" id="{E609303E-C99C-4778-AF8B-5AEBEC8F1182}"/>
               </a:ext>
             </a:extLst>
           </p:cNvPr>
@@ -5634,7 +5634,7 @@
           <p:cNvPr id="11" name="">
             <a:extLst xmlns:a="http://schemas.openxmlformats.org/drawingml/2006/main">
               <a:ext uri="{FF2B5EF4-FFF2-40B4-BE49-F238E27FC236}">
-                <a16:creationId xmlns:a16="http://schemas.microsoft.com/office/drawing/2014/main" id="{56318C66-33AD-4FC1-A219-30041E5296CE}"/>
+                <a16:creationId xmlns:a16="http://schemas.microsoft.com/office/drawing/2014/main" id="{E899EC1A-F58C-4154-A067-0557F8F2320A}"/>
               </a:ext>
             </a:extLst>
           </p:cNvPr>
@@ -5691,7 +5691,7 @@
           <p:cNvPr id="12" name="">
             <a:extLst xmlns:a="http://schemas.openxmlformats.org/drawingml/2006/main">
               <a:ext uri="{FF2B5EF4-FFF2-40B4-BE49-F238E27FC236}">
-                <a16:creationId xmlns:a16="http://schemas.microsoft.com/office/drawing/2014/main" id="{E4BBA343-90EC-41CA-95DB-E041CA9F68A4}"/>
+                <a16:creationId xmlns:a16="http://schemas.microsoft.com/office/drawing/2014/main" id="{E7075A68-6A0C-4DA5-8605-37B0E6A91257}"/>
               </a:ext>
             </a:extLst>
           </p:cNvPr>
@@ -5746,7 +5746,7 @@
     </p:spTree>
     <p:extLst>
       <p:ext uri="{BB962C8B-B14F-4D97-AF65-F5344CB8AC3E}">
-        <p14:creationId xmlns:p14="http://schemas.microsoft.com/office/powerpoint/2010/main" val="257452833"/>
+        <p14:creationId xmlns:p14="http://schemas.microsoft.com/office/powerpoint/2010/main" val="497130137"/>
       </p:ext>
     </p:extLst>
   </p:cSld>
@@ -5777,7 +5777,7 @@
           <p:cNvPr id="13" name="">
             <a:extLst xmlns:a="http://schemas.openxmlformats.org/drawingml/2006/main">
               <a:ext uri="{FF2B5EF4-FFF2-40B4-BE49-F238E27FC236}">
-                <a16:creationId xmlns:a16="http://schemas.microsoft.com/office/drawing/2014/main" id="{2DB4165C-C9AA-41BD-BB7A-016D8F340A2A}"/>
+                <a16:creationId xmlns:a16="http://schemas.microsoft.com/office/drawing/2014/main" id="{68926339-ACEF-4880-80CB-11358B97352C}"/>
               </a:ext>
             </a:extLst>
           </p:cNvPr>
@@ -5834,7 +5834,7 @@
           <p:cNvPr id="2" name="">
             <a:extLst xmlns:a="http://schemas.openxmlformats.org/drawingml/2006/main">
               <a:ext uri="{FF2B5EF4-FFF2-40B4-BE49-F238E27FC236}">
-                <a16:creationId xmlns:a16="http://schemas.microsoft.com/office/drawing/2014/main" id="{80658447-A23F-408E-B723-76515635E0D0}"/>
+                <a16:creationId xmlns:a16="http://schemas.microsoft.com/office/drawing/2014/main" id="{29DE96BA-C3FE-4E91-8A0E-CAD9C56E0337}"/>
               </a:ext>
             </a:extLst>
           </p:cNvPr>
@@ -5864,7 +5864,7 @@
           <p:cNvPr id="3" name="">
             <a:extLst xmlns:a="http://schemas.openxmlformats.org/drawingml/2006/main">
               <a:ext uri="{FF2B5EF4-FFF2-40B4-BE49-F238E27FC236}">
-                <a16:creationId xmlns:a16="http://schemas.microsoft.com/office/drawing/2014/main" id="{D4B99289-B6E2-46FF-9D66-D1185F824D99}"/>
+                <a16:creationId xmlns:a16="http://schemas.microsoft.com/office/drawing/2014/main" id="{37324CB8-16F7-41E2-A061-96299EA6FFA5}"/>
               </a:ext>
             </a:extLst>
           </p:cNvPr>
@@ -5921,7 +5921,7 @@
           <p:cNvPr id="4" name="">
             <a:extLst xmlns:a="http://schemas.openxmlformats.org/drawingml/2006/main">
               <a:ext uri="{FF2B5EF4-FFF2-40B4-BE49-F238E27FC236}">
-                <a16:creationId xmlns:a16="http://schemas.microsoft.com/office/drawing/2014/main" id="{65FB984E-A5D0-4DC8-B3C1-BC696F784CEB}"/>
+                <a16:creationId xmlns:a16="http://schemas.microsoft.com/office/drawing/2014/main" id="{B04E9E0E-75BE-489A-A345-D4B8C7F2D76E}"/>
               </a:ext>
             </a:extLst>
           </p:cNvPr>
@@ -5978,7 +5978,7 @@
           <p:cNvPr id="5" name="">
             <a:extLst xmlns:a="http://schemas.openxmlformats.org/drawingml/2006/main">
               <a:ext uri="{FF2B5EF4-FFF2-40B4-BE49-F238E27FC236}">
-                <a16:creationId xmlns:a16="http://schemas.microsoft.com/office/drawing/2014/main" id="{6694F615-5DEC-44B2-81B9-32736AC80374}"/>
+                <a16:creationId xmlns:a16="http://schemas.microsoft.com/office/drawing/2014/main" id="{023372A0-740C-49B5-AC61-F9CC82CC421E}"/>
               </a:ext>
             </a:extLst>
           </p:cNvPr>
@@ -6035,7 +6035,7 @@
           <p:cNvPr id="6" name="">
             <a:extLst xmlns:a="http://schemas.openxmlformats.org/drawingml/2006/main">
               <a:ext uri="{FF2B5EF4-FFF2-40B4-BE49-F238E27FC236}">
-                <a16:creationId xmlns:a16="http://schemas.microsoft.com/office/drawing/2014/main" id="{EC5156AD-4779-4E48-8BA2-2D8B418CF1CF}"/>
+                <a16:creationId xmlns:a16="http://schemas.microsoft.com/office/drawing/2014/main" id="{665D47A1-AEAF-4BDD-ABB3-3A87E054F78F}"/>
               </a:ext>
             </a:extLst>
           </p:cNvPr>
@@ -6092,7 +6092,7 @@
           <p:cNvPr id="7" name="">
             <a:extLst xmlns:a="http://schemas.openxmlformats.org/drawingml/2006/main">
               <a:ext uri="{FF2B5EF4-FFF2-40B4-BE49-F238E27FC236}">
-                <a16:creationId xmlns:a16="http://schemas.microsoft.com/office/drawing/2014/main" id="{9BC9F06D-C9B6-4B7C-B3FC-3D029DABCF5F}"/>
+                <a16:creationId xmlns:a16="http://schemas.microsoft.com/office/drawing/2014/main" id="{72B61EE1-E81B-4040-BAFF-F683769CC5AF}"/>
               </a:ext>
             </a:extLst>
           </p:cNvPr>
@@ -6122,7 +6122,7 @@
           <p:cNvPr id="8" name="">
             <a:extLst xmlns:a="http://schemas.openxmlformats.org/drawingml/2006/main">
               <a:ext uri="{FF2B5EF4-FFF2-40B4-BE49-F238E27FC236}">
-                <a16:creationId xmlns:a16="http://schemas.microsoft.com/office/drawing/2014/main" id="{3E058C66-3384-4132-85FC-2405248F2849}"/>
+                <a16:creationId xmlns:a16="http://schemas.microsoft.com/office/drawing/2014/main" id="{E86EBEC0-C9AB-4686-86E5-AFD53AE7516B}"/>
               </a:ext>
             </a:extLst>
           </p:cNvPr>
@@ -6179,7 +6179,7 @@
           <p:cNvPr id="9" name="">
             <a:extLst xmlns:a="http://schemas.openxmlformats.org/drawingml/2006/main">
               <a:ext uri="{FF2B5EF4-FFF2-40B4-BE49-F238E27FC236}">
-                <a16:creationId xmlns:a16="http://schemas.microsoft.com/office/drawing/2014/main" id="{29954B43-FF80-4318-882D-81800111711F}"/>
+                <a16:creationId xmlns:a16="http://schemas.microsoft.com/office/drawing/2014/main" id="{DB9DBD60-A11E-49AF-9837-03A39B8266AF}"/>
               </a:ext>
             </a:extLst>
           </p:cNvPr>
@@ -6236,7 +6236,7 @@
           <p:cNvPr id="10" name="">
             <a:extLst xmlns:a="http://schemas.openxmlformats.org/drawingml/2006/main">
               <a:ext uri="{FF2B5EF4-FFF2-40B4-BE49-F238E27FC236}">
-                <a16:creationId xmlns:a16="http://schemas.microsoft.com/office/drawing/2014/main" id="{FB31AD01-108E-4FA1-AAC7-634E230C4BB2}"/>
+                <a16:creationId xmlns:a16="http://schemas.microsoft.com/office/drawing/2014/main" id="{35E47611-E814-4FB0-903A-D0D2EC19300A}"/>
               </a:ext>
             </a:extLst>
           </p:cNvPr>
@@ -6266,7 +6266,7 @@
           <p:cNvPr id="11" name="">
             <a:extLst xmlns:a="http://schemas.openxmlformats.org/drawingml/2006/main">
               <a:ext uri="{FF2B5EF4-FFF2-40B4-BE49-F238E27FC236}">
-                <a16:creationId xmlns:a16="http://schemas.microsoft.com/office/drawing/2014/main" id="{8CB76420-374A-4592-90F6-AF8067D9E12E}"/>
+                <a16:creationId xmlns:a16="http://schemas.microsoft.com/office/drawing/2014/main" id="{A7451239-E68E-4AB1-9B45-CD322C62B4AA}"/>
               </a:ext>
             </a:extLst>
           </p:cNvPr>
@@ -6323,7 +6323,7 @@
           <p:cNvPr id="12" name="">
             <a:extLst xmlns:a="http://schemas.openxmlformats.org/drawingml/2006/main">
               <a:ext uri="{FF2B5EF4-FFF2-40B4-BE49-F238E27FC236}">
-                <a16:creationId xmlns:a16="http://schemas.microsoft.com/office/drawing/2014/main" id="{0247688F-D246-44A2-9947-E375A42E0157}"/>
+                <a16:creationId xmlns:a16="http://schemas.microsoft.com/office/drawing/2014/main" id="{0BE1A831-4815-4A87-84A4-C8B881FF0B00}"/>
               </a:ext>
             </a:extLst>
           </p:cNvPr>
@@ -6378,7 +6378,7 @@
     </p:spTree>
     <p:extLst>
       <p:ext uri="{BB962C8B-B14F-4D97-AF65-F5344CB8AC3E}">
-        <p14:creationId xmlns:p14="http://schemas.microsoft.com/office/powerpoint/2010/main" val="120495403"/>
+        <p14:creationId xmlns:p14="http://schemas.microsoft.com/office/powerpoint/2010/main" val="1561019973"/>
       </p:ext>
     </p:extLst>
   </p:cSld>

</xml_diff>